<commit_message>
Increase all PowerPoint font sizes — body 15pt, headings 18pt+
Co-Authored-By: Claude Sonnet 4.6 <noreply@anthropic.com>
</commit_message>
<xml_diff>
--- a/GRC_Analyst_Portfolio_Anel_Henning.pptx
+++ b/GRC_Analyst_Portfolio_Anel_Henning.pptx
@@ -3544,7 +3544,7 @@
           <a:p>
             <a:pPr algn="l"/>
             <a:r>
-              <a:rPr sz="1600" b="0" i="0">
+              <a:rPr sz="1800" b="0" i="0">
                 <a:solidFill>
                   <a:srgbClr val="CADCFC"/>
                 </a:solidFill>
@@ -3622,7 +3622,7 @@
           <a:p>
             <a:pPr algn="ctr"/>
             <a:r>
-              <a:rPr sz="1200" b="1" i="0">
+              <a:rPr sz="1500" b="1" i="0">
                 <a:solidFill>
                   <a:srgbClr val="FFFFFF"/>
                 </a:solidFill>
@@ -3700,7 +3700,7 @@
           <a:p>
             <a:pPr algn="ctr"/>
             <a:r>
-              <a:rPr sz="1200" b="1" i="0">
+              <a:rPr sz="1500" b="1" i="0">
                 <a:solidFill>
                   <a:srgbClr val="FFFFFF"/>
                 </a:solidFill>
@@ -3778,7 +3778,7 @@
           <a:p>
             <a:pPr algn="ctr"/>
             <a:r>
-              <a:rPr sz="1200" b="1" i="0">
+              <a:rPr sz="1500" b="1" i="0">
                 <a:solidFill>
                   <a:srgbClr val="FFFFFF"/>
                 </a:solidFill>
@@ -3813,7 +3813,7 @@
           <a:p>
             <a:pPr algn="l"/>
             <a:r>
-              <a:rPr sz="1100" b="0" i="1">
+              <a:rPr sz="1800" b="0" i="1">
                 <a:solidFill>
                   <a:srgbClr val="55657A"/>
                 </a:solidFill>
@@ -3952,7 +3952,7 @@
           <a:p>
             <a:pPr algn="l"/>
             <a:r>
-              <a:rPr sz="1200" b="0" i="1">
+              <a:rPr sz="1500" b="0" i="1">
                 <a:solidFill>
                   <a:srgbClr val="CADCFC"/>
                 </a:solidFill>
@@ -4065,7 +4065,7 @@
           <a:p>
             <a:pPr algn="ctr"/>
             <a:r>
-              <a:rPr sz="1000" b="1" i="0">
+              <a:rPr sz="1500" b="1" i="0">
                 <a:solidFill>
                   <a:srgbClr val="FFFFFF"/>
                 </a:solidFill>
@@ -4100,7 +4100,7 @@
           <a:p>
             <a:pPr algn="ctr"/>
             <a:r>
-              <a:rPr sz="900" b="0" i="1">
+              <a:rPr sz="1500" b="0" i="1">
                 <a:solidFill>
                   <a:srgbClr val="CADCFC"/>
                 </a:solidFill>
@@ -4213,7 +4213,7 @@
           <a:p>
             <a:pPr algn="ctr"/>
             <a:r>
-              <a:rPr sz="1000" b="1" i="0">
+              <a:rPr sz="1500" b="1" i="0">
                 <a:solidFill>
                   <a:srgbClr val="FFFFFF"/>
                 </a:solidFill>
@@ -4248,7 +4248,7 @@
           <a:p>
             <a:pPr algn="ctr"/>
             <a:r>
-              <a:rPr sz="900" b="0" i="1">
+              <a:rPr sz="1500" b="0" i="1">
                 <a:solidFill>
                   <a:srgbClr val="CADCFC"/>
                 </a:solidFill>
@@ -4361,7 +4361,7 @@
           <a:p>
             <a:pPr algn="ctr"/>
             <a:r>
-              <a:rPr sz="1000" b="1" i="0">
+              <a:rPr sz="1500" b="1" i="0">
                 <a:solidFill>
                   <a:srgbClr val="FFFFFF"/>
                 </a:solidFill>
@@ -4396,7 +4396,7 @@
           <a:p>
             <a:pPr algn="ctr"/>
             <a:r>
-              <a:rPr sz="900" b="0" i="1">
+              <a:rPr sz="1500" b="0" i="1">
                 <a:solidFill>
                   <a:srgbClr val="CADCFC"/>
                 </a:solidFill>
@@ -4509,7 +4509,7 @@
           <a:p>
             <a:pPr algn="ctr"/>
             <a:r>
-              <a:rPr sz="1000" b="1" i="0">
+              <a:rPr sz="1500" b="1" i="0">
                 <a:solidFill>
                   <a:srgbClr val="FFFFFF"/>
                 </a:solidFill>
@@ -4544,7 +4544,7 @@
           <a:p>
             <a:pPr algn="ctr"/>
             <a:r>
-              <a:rPr sz="900" b="0" i="1">
+              <a:rPr sz="1500" b="0" i="1">
                 <a:solidFill>
                   <a:srgbClr val="CADCFC"/>
                 </a:solidFill>
@@ -4657,7 +4657,7 @@
           <a:p>
             <a:pPr algn="ctr"/>
             <a:r>
-              <a:rPr sz="1000" b="1" i="0">
+              <a:rPr sz="1500" b="1" i="0">
                 <a:solidFill>
                   <a:srgbClr val="FFFFFF"/>
                 </a:solidFill>
@@ -4692,7 +4692,7 @@
           <a:p>
             <a:pPr algn="ctr"/>
             <a:r>
-              <a:rPr sz="900" b="0" i="1">
+              <a:rPr sz="1500" b="0" i="1">
                 <a:solidFill>
                   <a:srgbClr val="CADCFC"/>
                 </a:solidFill>
@@ -4805,7 +4805,7 @@
           <a:p>
             <a:pPr algn="ctr"/>
             <a:r>
-              <a:rPr sz="1000" b="1" i="0">
+              <a:rPr sz="1500" b="1" i="0">
                 <a:solidFill>
                   <a:srgbClr val="FFFFFF"/>
                 </a:solidFill>
@@ -4840,7 +4840,7 @@
           <a:p>
             <a:pPr algn="ctr"/>
             <a:r>
-              <a:rPr sz="900" b="0" i="1">
+              <a:rPr sz="1500" b="0" i="1">
                 <a:solidFill>
                   <a:srgbClr val="CADCFC"/>
                 </a:solidFill>
@@ -4953,7 +4953,7 @@
           <a:p>
             <a:pPr algn="ctr"/>
             <a:r>
-              <a:rPr sz="1000" b="1" i="0">
+              <a:rPr sz="1500" b="1" i="0">
                 <a:solidFill>
                   <a:srgbClr val="FFFFFF"/>
                 </a:solidFill>
@@ -4988,7 +4988,7 @@
           <a:p>
             <a:pPr algn="ctr"/>
             <a:r>
-              <a:rPr sz="900" b="0" i="1">
+              <a:rPr sz="1500" b="0" i="1">
                 <a:solidFill>
                   <a:srgbClr val="CADCFC"/>
                 </a:solidFill>
@@ -5023,7 +5023,7 @@
           <a:p>
             <a:pPr algn="ctr"/>
             <a:r>
-              <a:rPr sz="1100" b="0" i="1">
+              <a:rPr sz="1800" b="0" i="1">
                 <a:solidFill>
                   <a:srgbClr val="CADCFC"/>
                 </a:solidFill>
@@ -5210,7 +5210,7 @@
               </a:spcAft>
             </a:pPr>
             <a:r>
-              <a:rPr sz="1400">
+              <a:rPr sz="1800">
                 <a:solidFill>
                   <a:srgbClr val="CADCFC"/>
                 </a:solidFill>
@@ -5226,7 +5226,7 @@
               </a:spcAft>
             </a:pPr>
             <a:r>
-              <a:rPr sz="1400">
+              <a:rPr sz="1800">
                 <a:solidFill>
                   <a:srgbClr val="CADCFC"/>
                 </a:solidFill>
@@ -5242,7 +5242,7 @@
               </a:spcAft>
             </a:pPr>
             <a:r>
-              <a:rPr sz="1400">
+              <a:rPr sz="1800">
                 <a:solidFill>
                   <a:srgbClr val="CADCFC"/>
                 </a:solidFill>
@@ -5277,7 +5277,7 @@
           <a:p>
             <a:pPr algn="l"/>
             <a:r>
-              <a:rPr sz="1200" b="1" i="0">
+              <a:rPr sz="1500" b="1" i="0">
                 <a:solidFill>
                   <a:srgbClr val="CADCFC"/>
                 </a:solidFill>
@@ -5355,7 +5355,7 @@
           <a:p>
             <a:pPr algn="ctr"/>
             <a:r>
-              <a:rPr sz="1100" b="1" i="0">
+              <a:rPr sz="1800" b="1" i="0">
                 <a:solidFill>
                   <a:srgbClr val="FFFFFF"/>
                 </a:solidFill>
@@ -5433,7 +5433,7 @@
           <a:p>
             <a:pPr algn="ctr"/>
             <a:r>
-              <a:rPr sz="1100" b="1" i="0">
+              <a:rPr sz="1800" b="1" i="0">
                 <a:solidFill>
                   <a:srgbClr val="FFFFFF"/>
                 </a:solidFill>
@@ -5511,7 +5511,7 @@
           <a:p>
             <a:pPr algn="ctr"/>
             <a:r>
-              <a:rPr sz="1100" b="1" i="0">
+              <a:rPr sz="1800" b="1" i="0">
                 <a:solidFill>
                   <a:srgbClr val="FFFFFF"/>
                 </a:solidFill>
@@ -5589,7 +5589,7 @@
           <a:p>
             <a:pPr algn="ctr"/>
             <a:r>
-              <a:rPr sz="1100" b="1" i="0">
+              <a:rPr sz="1800" b="1" i="0">
                 <a:solidFill>
                   <a:srgbClr val="FFFFFF"/>
                 </a:solidFill>
@@ -5667,7 +5667,7 @@
           <a:p>
             <a:pPr algn="ctr"/>
             <a:r>
-              <a:rPr sz="1100" b="1" i="0">
+              <a:rPr sz="1800" b="1" i="0">
                 <a:solidFill>
                   <a:srgbClr val="FFFFFF"/>
                 </a:solidFill>
@@ -5745,7 +5745,7 @@
           <a:p>
             <a:pPr algn="ctr"/>
             <a:r>
-              <a:rPr sz="1100" b="1" i="0">
+              <a:rPr sz="1800" b="1" i="0">
                 <a:solidFill>
                   <a:srgbClr val="FFFFFF"/>
                 </a:solidFill>
@@ -5823,7 +5823,7 @@
           <a:p>
             <a:pPr algn="ctr"/>
             <a:r>
-              <a:rPr sz="1100" b="1" i="0">
+              <a:rPr sz="1800" b="1" i="0">
                 <a:solidFill>
                   <a:srgbClr val="FFFFFF"/>
                 </a:solidFill>
@@ -5901,7 +5901,7 @@
           <a:p>
             <a:pPr algn="ctr"/>
             <a:r>
-              <a:rPr sz="1100" b="1" i="0">
+              <a:rPr sz="1800" b="1" i="0">
                 <a:solidFill>
                   <a:srgbClr val="FFFFFF"/>
                 </a:solidFill>
@@ -5936,7 +5936,7 @@
           <a:p>
             <a:pPr algn="l"/>
             <a:r>
-              <a:rPr sz="1100" b="0" i="1">
+              <a:rPr sz="1800" b="0" i="1">
                 <a:solidFill>
                   <a:srgbClr val="55657A"/>
                 </a:solidFill>
@@ -6075,7 +6075,7 @@
           <a:p>
             <a:pPr algn="l"/>
             <a:r>
-              <a:rPr sz="1300" b="0" i="0">
+              <a:rPr sz="1500" b="0" i="0">
                 <a:solidFill>
                   <a:srgbClr val="55657A"/>
                 </a:solidFill>
@@ -6196,7 +6196,7 @@
           <a:p>
             <a:pPr algn="l"/>
             <a:r>
-              <a:rPr sz="1100" b="1" i="0">
+              <a:rPr sz="1800" b="1" i="0">
                 <a:solidFill>
                   <a:srgbClr val="FFFFFF"/>
                 </a:solidFill>
@@ -6235,7 +6235,7 @@
               </a:spcAft>
             </a:pPr>
             <a:r>
-              <a:rPr sz="1100">
+              <a:rPr sz="1800">
                 <a:solidFill>
                   <a:srgbClr val="1E273D"/>
                 </a:solidFill>
@@ -6251,7 +6251,7 @@
               </a:spcAft>
             </a:pPr>
             <a:r>
-              <a:rPr sz="1100">
+              <a:rPr sz="1800">
                 <a:solidFill>
                   <a:srgbClr val="1E273D"/>
                 </a:solidFill>
@@ -6267,7 +6267,7 @@
               </a:spcAft>
             </a:pPr>
             <a:r>
-              <a:rPr sz="1100">
+              <a:rPr sz="1800">
                 <a:solidFill>
                   <a:srgbClr val="1E273D"/>
                 </a:solidFill>
@@ -6283,7 +6283,7 @@
               </a:spcAft>
             </a:pPr>
             <a:r>
-              <a:rPr sz="1100">
+              <a:rPr sz="1800">
                 <a:solidFill>
                   <a:srgbClr val="1E273D"/>
                 </a:solidFill>
@@ -6299,7 +6299,7 @@
               </a:spcAft>
             </a:pPr>
             <a:r>
-              <a:rPr sz="1100">
+              <a:rPr sz="1800">
                 <a:solidFill>
                   <a:srgbClr val="1E273D"/>
                 </a:solidFill>
@@ -6420,7 +6420,7 @@
           <a:p>
             <a:pPr algn="l"/>
             <a:r>
-              <a:rPr sz="1100" b="1" i="0">
+              <a:rPr sz="1800" b="1" i="0">
                 <a:solidFill>
                   <a:srgbClr val="FFFFFF"/>
                 </a:solidFill>
@@ -6459,7 +6459,7 @@
               </a:spcAft>
             </a:pPr>
             <a:r>
-              <a:rPr sz="1100">
+              <a:rPr sz="1800">
                 <a:solidFill>
                   <a:srgbClr val="1E273D"/>
                 </a:solidFill>
@@ -6475,7 +6475,7 @@
               </a:spcAft>
             </a:pPr>
             <a:r>
-              <a:rPr sz="1100">
+              <a:rPr sz="1800">
                 <a:solidFill>
                   <a:srgbClr val="1E273D"/>
                 </a:solidFill>
@@ -6491,7 +6491,7 @@
               </a:spcAft>
             </a:pPr>
             <a:r>
-              <a:rPr sz="1100">
+              <a:rPr sz="1800">
                 <a:solidFill>
                   <a:srgbClr val="1E273D"/>
                 </a:solidFill>
@@ -6507,7 +6507,7 @@
               </a:spcAft>
             </a:pPr>
             <a:r>
-              <a:rPr sz="1100">
+              <a:rPr sz="1800">
                 <a:solidFill>
                   <a:srgbClr val="1E273D"/>
                 </a:solidFill>
@@ -6523,7 +6523,7 @@
               </a:spcAft>
             </a:pPr>
             <a:r>
-              <a:rPr sz="1100">
+              <a:rPr sz="1800">
                 <a:solidFill>
                   <a:srgbClr val="1E273D"/>
                 </a:solidFill>
@@ -6644,7 +6644,7 @@
           <a:p>
             <a:pPr algn="l"/>
             <a:r>
-              <a:rPr sz="1100" b="1" i="0">
+              <a:rPr sz="1800" b="1" i="0">
                 <a:solidFill>
                   <a:srgbClr val="FFFFFF"/>
                 </a:solidFill>
@@ -6683,7 +6683,7 @@
               </a:spcAft>
             </a:pPr>
             <a:r>
-              <a:rPr sz="1100">
+              <a:rPr sz="1800">
                 <a:solidFill>
                   <a:srgbClr val="1E273D"/>
                 </a:solidFill>
@@ -6699,7 +6699,7 @@
               </a:spcAft>
             </a:pPr>
             <a:r>
-              <a:rPr sz="1100">
+              <a:rPr sz="1800">
                 <a:solidFill>
                   <a:srgbClr val="1E273D"/>
                 </a:solidFill>
@@ -6715,7 +6715,7 @@
               </a:spcAft>
             </a:pPr>
             <a:r>
-              <a:rPr sz="1100">
+              <a:rPr sz="1800">
                 <a:solidFill>
                   <a:srgbClr val="1E273D"/>
                 </a:solidFill>
@@ -6731,7 +6731,7 @@
               </a:spcAft>
             </a:pPr>
             <a:r>
-              <a:rPr sz="1100">
+              <a:rPr sz="1800">
                 <a:solidFill>
                   <a:srgbClr val="1E273D"/>
                 </a:solidFill>
@@ -6747,7 +6747,7 @@
               </a:spcAft>
             </a:pPr>
             <a:r>
-              <a:rPr sz="1100">
+              <a:rPr sz="1800">
                 <a:solidFill>
                   <a:srgbClr val="1E273D"/>
                 </a:solidFill>
@@ -6782,7 +6782,7 @@
           <a:p>
             <a:pPr algn="l"/>
             <a:r>
-              <a:rPr sz="1000" b="0" i="1">
+              <a:rPr sz="1500" b="0" i="1">
                 <a:solidFill>
                   <a:srgbClr val="55657A"/>
                 </a:solidFill>
@@ -6964,7 +6964,7 @@
           <a:p>
             <a:pPr algn="ctr"/>
             <a:r>
-              <a:rPr sz="1100" b="1" i="0">
+              <a:rPr sz="1800" b="1" i="0">
                 <a:solidFill>
                   <a:srgbClr val="FFFFFF"/>
                 </a:solidFill>
@@ -7041,7 +7041,7 @@
           <a:lstStyle/>
           <a:p>
             <a:r>
-              <a:rPr sz="800" b="1">
+              <a:rPr sz="1100" b="1">
                 <a:solidFill>
                   <a:srgbClr val="028090"/>
                 </a:solidFill>
@@ -7076,7 +7076,7 @@
           <a:p>
             <a:pPr algn="l"/>
             <a:r>
-              <a:rPr sz="1200" b="0" i="0">
+              <a:rPr sz="1500" b="0" i="0">
                 <a:solidFill>
                   <a:srgbClr val="1E273D"/>
                 </a:solidFill>
@@ -7155,7 +7155,7 @@
           <a:lstStyle/>
           <a:p>
             <a:r>
-              <a:rPr sz="800" b="1">
+              <a:rPr sz="1100" b="1">
                 <a:solidFill>
                   <a:srgbClr val="028090"/>
                 </a:solidFill>
@@ -7194,7 +7194,7 @@
               </a:spcAft>
             </a:pPr>
             <a:r>
-              <a:rPr sz="1200">
+              <a:rPr sz="1500">
                 <a:solidFill>
                   <a:srgbClr val="1E273D"/>
                 </a:solidFill>
@@ -7210,7 +7210,7 @@
               </a:spcAft>
             </a:pPr>
             <a:r>
-              <a:rPr sz="1200">
+              <a:rPr sz="1500">
                 <a:solidFill>
                   <a:srgbClr val="1E273D"/>
                 </a:solidFill>
@@ -7226,7 +7226,7 @@
               </a:spcAft>
             </a:pPr>
             <a:r>
-              <a:rPr sz="1200">
+              <a:rPr sz="1500">
                 <a:solidFill>
                   <a:srgbClr val="1E273D"/>
                 </a:solidFill>
@@ -7242,7 +7242,7 @@
               </a:spcAft>
             </a:pPr>
             <a:r>
-              <a:rPr sz="1200">
+              <a:rPr sz="1500">
                 <a:solidFill>
                   <a:srgbClr val="1E273D"/>
                 </a:solidFill>
@@ -7319,7 +7319,7 @@
           <a:lstStyle/>
           <a:p>
             <a:r>
-              <a:rPr sz="900" b="1">
+              <a:rPr sz="1500" b="1">
                 <a:solidFill>
                   <a:srgbClr val="F5C518"/>
                 </a:solidFill>
@@ -7354,7 +7354,7 @@
           <a:p>
             <a:pPr algn="l"/>
             <a:r>
-              <a:rPr sz="1600" b="1" i="0">
+              <a:rPr sz="1800" b="1" i="0">
                 <a:solidFill>
                   <a:srgbClr val="FFFFFF"/>
                 </a:solidFill>
@@ -7389,7 +7389,7 @@
           <a:p>
             <a:pPr algn="l"/>
             <a:r>
-              <a:rPr sz="1200" b="0" i="0">
+              <a:rPr sz="1500" b="0" i="0">
                 <a:solidFill>
                   <a:srgbClr val="CADCFC"/>
                 </a:solidFill>
@@ -7571,7 +7571,7 @@
           <a:p>
             <a:pPr algn="ctr"/>
             <a:r>
-              <a:rPr sz="1100" b="1" i="0">
+              <a:rPr sz="1800" b="1" i="0">
                 <a:solidFill>
                   <a:srgbClr val="FFFFFF"/>
                 </a:solidFill>
@@ -7648,7 +7648,7 @@
           <a:lstStyle/>
           <a:p>
             <a:r>
-              <a:rPr sz="800" b="1">
+              <a:rPr sz="1100" b="1">
                 <a:solidFill>
                   <a:srgbClr val="028090"/>
                 </a:solidFill>
@@ -7683,7 +7683,7 @@
           <a:p>
             <a:pPr algn="l"/>
             <a:r>
-              <a:rPr sz="1200" b="0" i="0">
+              <a:rPr sz="1500" b="0" i="0">
                 <a:solidFill>
                   <a:srgbClr val="1E273D"/>
                 </a:solidFill>
@@ -7762,7 +7762,7 @@
           <a:lstStyle/>
           <a:p>
             <a:r>
-              <a:rPr sz="800" b="1">
+              <a:rPr sz="1100" b="1">
                 <a:solidFill>
                   <a:srgbClr val="028090"/>
                 </a:solidFill>
@@ -7801,7 +7801,7 @@
               </a:spcAft>
             </a:pPr>
             <a:r>
-              <a:rPr sz="1200">
+              <a:rPr sz="1500">
                 <a:solidFill>
                   <a:srgbClr val="1E273D"/>
                 </a:solidFill>
@@ -7817,7 +7817,7 @@
               </a:spcAft>
             </a:pPr>
             <a:r>
-              <a:rPr sz="1200">
+              <a:rPr sz="1500">
                 <a:solidFill>
                   <a:srgbClr val="1E273D"/>
                 </a:solidFill>
@@ -7833,7 +7833,7 @@
               </a:spcAft>
             </a:pPr>
             <a:r>
-              <a:rPr sz="1200">
+              <a:rPr sz="1500">
                 <a:solidFill>
                   <a:srgbClr val="1E273D"/>
                 </a:solidFill>
@@ -7849,7 +7849,7 @@
               </a:spcAft>
             </a:pPr>
             <a:r>
-              <a:rPr sz="1200">
+              <a:rPr sz="1500">
                 <a:solidFill>
                   <a:srgbClr val="1E273D"/>
                 </a:solidFill>
@@ -7926,7 +7926,7 @@
           <a:lstStyle/>
           <a:p>
             <a:r>
-              <a:rPr sz="900" b="1">
+              <a:rPr sz="1500" b="1">
                 <a:solidFill>
                   <a:srgbClr val="F5C518"/>
                 </a:solidFill>
@@ -7961,7 +7961,7 @@
           <a:p>
             <a:pPr algn="l"/>
             <a:r>
-              <a:rPr sz="1600" b="1" i="0">
+              <a:rPr sz="1800" b="1" i="0">
                 <a:solidFill>
                   <a:srgbClr val="FFFFFF"/>
                 </a:solidFill>
@@ -7996,7 +7996,7 @@
           <a:p>
             <a:pPr algn="l"/>
             <a:r>
-              <a:rPr sz="1200" b="0" i="0">
+              <a:rPr sz="1500" b="0" i="0">
                 <a:solidFill>
                   <a:srgbClr val="CADCFC"/>
                 </a:solidFill>
@@ -8178,7 +8178,7 @@
           <a:p>
             <a:pPr algn="ctr"/>
             <a:r>
-              <a:rPr sz="1100" b="1" i="0">
+              <a:rPr sz="1800" b="1" i="0">
                 <a:solidFill>
                   <a:srgbClr val="FFFFFF"/>
                 </a:solidFill>
@@ -8255,7 +8255,7 @@
           <a:lstStyle/>
           <a:p>
             <a:r>
-              <a:rPr sz="800" b="1">
+              <a:rPr sz="1100" b="1">
                 <a:solidFill>
                   <a:srgbClr val="028090"/>
                 </a:solidFill>
@@ -8290,7 +8290,7 @@
           <a:p>
             <a:pPr algn="l"/>
             <a:r>
-              <a:rPr sz="1200" b="0" i="0">
+              <a:rPr sz="1500" b="0" i="0">
                 <a:solidFill>
                   <a:srgbClr val="1E273D"/>
                 </a:solidFill>
@@ -8369,7 +8369,7 @@
           <a:lstStyle/>
           <a:p>
             <a:r>
-              <a:rPr sz="800" b="1">
+              <a:rPr sz="1100" b="1">
                 <a:solidFill>
                   <a:srgbClr val="028090"/>
                 </a:solidFill>
@@ -8408,7 +8408,7 @@
               </a:spcAft>
             </a:pPr>
             <a:r>
-              <a:rPr sz="1200">
+              <a:rPr sz="1500">
                 <a:solidFill>
                   <a:srgbClr val="1E273D"/>
                 </a:solidFill>
@@ -8424,7 +8424,7 @@
               </a:spcAft>
             </a:pPr>
             <a:r>
-              <a:rPr sz="1200">
+              <a:rPr sz="1500">
                 <a:solidFill>
                   <a:srgbClr val="1E273D"/>
                 </a:solidFill>
@@ -8440,7 +8440,7 @@
               </a:spcAft>
             </a:pPr>
             <a:r>
-              <a:rPr sz="1200">
+              <a:rPr sz="1500">
                 <a:solidFill>
                   <a:srgbClr val="1E273D"/>
                 </a:solidFill>
@@ -8456,7 +8456,7 @@
               </a:spcAft>
             </a:pPr>
             <a:r>
-              <a:rPr sz="1200">
+              <a:rPr sz="1500">
                 <a:solidFill>
                   <a:srgbClr val="1E273D"/>
                 </a:solidFill>
@@ -8533,7 +8533,7 @@
           <a:lstStyle/>
           <a:p>
             <a:r>
-              <a:rPr sz="900" b="1">
+              <a:rPr sz="1500" b="1">
                 <a:solidFill>
                   <a:srgbClr val="F5C518"/>
                 </a:solidFill>
@@ -8568,7 +8568,7 @@
           <a:p>
             <a:pPr algn="l"/>
             <a:r>
-              <a:rPr sz="1600" b="1" i="0">
+              <a:rPr sz="1800" b="1" i="0">
                 <a:solidFill>
                   <a:srgbClr val="FFFFFF"/>
                 </a:solidFill>
@@ -8603,7 +8603,7 @@
           <a:p>
             <a:pPr algn="l"/>
             <a:r>
-              <a:rPr sz="1200" b="0" i="0">
+              <a:rPr sz="1500" b="0" i="0">
                 <a:solidFill>
                   <a:srgbClr val="CADCFC"/>
                 </a:solidFill>
@@ -8785,7 +8785,7 @@
           <a:p>
             <a:pPr algn="ctr"/>
             <a:r>
-              <a:rPr sz="1100" b="1" i="0">
+              <a:rPr sz="1800" b="1" i="0">
                 <a:solidFill>
                   <a:srgbClr val="FFFFFF"/>
                 </a:solidFill>
@@ -8862,7 +8862,7 @@
           <a:lstStyle/>
           <a:p>
             <a:r>
-              <a:rPr sz="800" b="1">
+              <a:rPr sz="1100" b="1">
                 <a:solidFill>
                   <a:srgbClr val="028090"/>
                 </a:solidFill>
@@ -8897,7 +8897,7 @@
           <a:p>
             <a:pPr algn="l"/>
             <a:r>
-              <a:rPr sz="1200" b="0" i="0">
+              <a:rPr sz="1500" b="0" i="0">
                 <a:solidFill>
                   <a:srgbClr val="1E273D"/>
                 </a:solidFill>
@@ -8976,7 +8976,7 @@
           <a:lstStyle/>
           <a:p>
             <a:r>
-              <a:rPr sz="800" b="1">
+              <a:rPr sz="1100" b="1">
                 <a:solidFill>
                   <a:srgbClr val="028090"/>
                 </a:solidFill>
@@ -9015,7 +9015,7 @@
               </a:spcAft>
             </a:pPr>
             <a:r>
-              <a:rPr sz="1200">
+              <a:rPr sz="1500">
                 <a:solidFill>
                   <a:srgbClr val="1E273D"/>
                 </a:solidFill>
@@ -9031,7 +9031,7 @@
               </a:spcAft>
             </a:pPr>
             <a:r>
-              <a:rPr sz="1200">
+              <a:rPr sz="1500">
                 <a:solidFill>
                   <a:srgbClr val="1E273D"/>
                 </a:solidFill>
@@ -9047,7 +9047,7 @@
               </a:spcAft>
             </a:pPr>
             <a:r>
-              <a:rPr sz="1200">
+              <a:rPr sz="1500">
                 <a:solidFill>
                   <a:srgbClr val="1E273D"/>
                 </a:solidFill>
@@ -9063,7 +9063,7 @@
               </a:spcAft>
             </a:pPr>
             <a:r>
-              <a:rPr sz="1200">
+              <a:rPr sz="1500">
                 <a:solidFill>
                   <a:srgbClr val="1E273D"/>
                 </a:solidFill>
@@ -9140,7 +9140,7 @@
           <a:lstStyle/>
           <a:p>
             <a:r>
-              <a:rPr sz="900" b="1">
+              <a:rPr sz="1500" b="1">
                 <a:solidFill>
                   <a:srgbClr val="F5C518"/>
                 </a:solidFill>
@@ -9175,7 +9175,7 @@
           <a:p>
             <a:pPr algn="l"/>
             <a:r>
-              <a:rPr sz="1600" b="1" i="0">
+              <a:rPr sz="1800" b="1" i="0">
                 <a:solidFill>
                   <a:srgbClr val="FFFFFF"/>
                 </a:solidFill>
@@ -9210,7 +9210,7 @@
           <a:p>
             <a:pPr algn="l"/>
             <a:r>
-              <a:rPr sz="1200" b="0" i="0">
+              <a:rPr sz="1500" b="0" i="0">
                 <a:solidFill>
                   <a:srgbClr val="CADCFC"/>
                 </a:solidFill>
@@ -9392,7 +9392,7 @@
           <a:p>
             <a:pPr algn="ctr"/>
             <a:r>
-              <a:rPr sz="1100" b="1" i="0">
+              <a:rPr sz="1800" b="1" i="0">
                 <a:solidFill>
                   <a:srgbClr val="FFFFFF"/>
                 </a:solidFill>
@@ -9469,7 +9469,7 @@
           <a:lstStyle/>
           <a:p>
             <a:r>
-              <a:rPr sz="800" b="1">
+              <a:rPr sz="1100" b="1">
                 <a:solidFill>
                   <a:srgbClr val="028090"/>
                 </a:solidFill>
@@ -9504,7 +9504,7 @@
           <a:p>
             <a:pPr algn="l"/>
             <a:r>
-              <a:rPr sz="1200" b="0" i="0">
+              <a:rPr sz="1500" b="0" i="0">
                 <a:solidFill>
                   <a:srgbClr val="1E273D"/>
                 </a:solidFill>
@@ -9583,7 +9583,7 @@
           <a:lstStyle/>
           <a:p>
             <a:r>
-              <a:rPr sz="800" b="1">
+              <a:rPr sz="1100" b="1">
                 <a:solidFill>
                   <a:srgbClr val="028090"/>
                 </a:solidFill>
@@ -9622,7 +9622,7 @@
               </a:spcAft>
             </a:pPr>
             <a:r>
-              <a:rPr sz="1200">
+              <a:rPr sz="1500">
                 <a:solidFill>
                   <a:srgbClr val="1E273D"/>
                 </a:solidFill>
@@ -9638,7 +9638,7 @@
               </a:spcAft>
             </a:pPr>
             <a:r>
-              <a:rPr sz="1200">
+              <a:rPr sz="1500">
                 <a:solidFill>
                   <a:srgbClr val="1E273D"/>
                 </a:solidFill>
@@ -9654,7 +9654,7 @@
               </a:spcAft>
             </a:pPr>
             <a:r>
-              <a:rPr sz="1200">
+              <a:rPr sz="1500">
                 <a:solidFill>
                   <a:srgbClr val="1E273D"/>
                 </a:solidFill>
@@ -9670,7 +9670,7 @@
               </a:spcAft>
             </a:pPr>
             <a:r>
-              <a:rPr sz="1200">
+              <a:rPr sz="1500">
                 <a:solidFill>
                   <a:srgbClr val="1E273D"/>
                 </a:solidFill>
@@ -9747,7 +9747,7 @@
           <a:lstStyle/>
           <a:p>
             <a:r>
-              <a:rPr sz="900" b="1">
+              <a:rPr sz="1500" b="1">
                 <a:solidFill>
                   <a:srgbClr val="F5C518"/>
                 </a:solidFill>
@@ -9782,7 +9782,7 @@
           <a:p>
             <a:pPr algn="l"/>
             <a:r>
-              <a:rPr sz="1600" b="1" i="0">
+              <a:rPr sz="1800" b="1" i="0">
                 <a:solidFill>
                   <a:srgbClr val="FFFFFF"/>
                 </a:solidFill>
@@ -9817,7 +9817,7 @@
           <a:p>
             <a:pPr algn="l"/>
             <a:r>
-              <a:rPr sz="1200" b="0" i="0">
+              <a:rPr sz="1500" b="0" i="0">
                 <a:solidFill>
                   <a:srgbClr val="CADCFC"/>
                 </a:solidFill>
@@ -9999,7 +9999,7 @@
           <a:p>
             <a:pPr algn="ctr"/>
             <a:r>
-              <a:rPr sz="1100" b="1" i="0">
+              <a:rPr sz="1800" b="1" i="0">
                 <a:solidFill>
                   <a:srgbClr val="FFFFFF"/>
                 </a:solidFill>
@@ -10076,7 +10076,7 @@
           <a:lstStyle/>
           <a:p>
             <a:r>
-              <a:rPr sz="800" b="1">
+              <a:rPr sz="1100" b="1">
                 <a:solidFill>
                   <a:srgbClr val="028090"/>
                 </a:solidFill>
@@ -10111,7 +10111,7 @@
           <a:p>
             <a:pPr algn="l"/>
             <a:r>
-              <a:rPr sz="1200" b="0" i="0">
+              <a:rPr sz="1500" b="0" i="0">
                 <a:solidFill>
                   <a:srgbClr val="1E273D"/>
                 </a:solidFill>
@@ -10190,7 +10190,7 @@
           <a:lstStyle/>
           <a:p>
             <a:r>
-              <a:rPr sz="800" b="1">
+              <a:rPr sz="1100" b="1">
                 <a:solidFill>
                   <a:srgbClr val="028090"/>
                 </a:solidFill>
@@ -10229,7 +10229,7 @@
               </a:spcAft>
             </a:pPr>
             <a:r>
-              <a:rPr sz="1200">
+              <a:rPr sz="1500">
                 <a:solidFill>
                   <a:srgbClr val="1E273D"/>
                 </a:solidFill>
@@ -10245,7 +10245,7 @@
               </a:spcAft>
             </a:pPr>
             <a:r>
-              <a:rPr sz="1200">
+              <a:rPr sz="1500">
                 <a:solidFill>
                   <a:srgbClr val="1E273D"/>
                 </a:solidFill>
@@ -10261,7 +10261,7 @@
               </a:spcAft>
             </a:pPr>
             <a:r>
-              <a:rPr sz="1200">
+              <a:rPr sz="1500">
                 <a:solidFill>
                   <a:srgbClr val="1E273D"/>
                 </a:solidFill>
@@ -10277,7 +10277,7 @@
               </a:spcAft>
             </a:pPr>
             <a:r>
-              <a:rPr sz="1200">
+              <a:rPr sz="1500">
                 <a:solidFill>
                   <a:srgbClr val="1E273D"/>
                 </a:solidFill>
@@ -10354,7 +10354,7 @@
           <a:lstStyle/>
           <a:p>
             <a:r>
-              <a:rPr sz="900" b="1">
+              <a:rPr sz="1500" b="1">
                 <a:solidFill>
                   <a:srgbClr val="F5C518"/>
                 </a:solidFill>
@@ -10389,7 +10389,7 @@
           <a:p>
             <a:pPr algn="l"/>
             <a:r>
-              <a:rPr sz="1600" b="1" i="0">
+              <a:rPr sz="1800" b="1" i="0">
                 <a:solidFill>
                   <a:srgbClr val="FFFFFF"/>
                 </a:solidFill>
@@ -10424,7 +10424,7 @@
           <a:p>
             <a:pPr algn="l"/>
             <a:r>
-              <a:rPr sz="1200" b="0" i="0">
+              <a:rPr sz="1500" b="0" i="0">
                 <a:solidFill>
                   <a:srgbClr val="CADCFC"/>
                 </a:solidFill>
@@ -10606,7 +10606,7 @@
           <a:p>
             <a:pPr algn="ctr"/>
             <a:r>
-              <a:rPr sz="1100" b="1" i="0">
+              <a:rPr sz="1800" b="1" i="0">
                 <a:solidFill>
                   <a:srgbClr val="FFFFFF"/>
                 </a:solidFill>
@@ -10683,7 +10683,7 @@
           <a:lstStyle/>
           <a:p>
             <a:r>
-              <a:rPr sz="800" b="1">
+              <a:rPr sz="1100" b="1">
                 <a:solidFill>
                   <a:srgbClr val="028090"/>
                 </a:solidFill>
@@ -10718,7 +10718,7 @@
           <a:p>
             <a:pPr algn="l"/>
             <a:r>
-              <a:rPr sz="1200" b="0" i="0">
+              <a:rPr sz="1500" b="0" i="0">
                 <a:solidFill>
                   <a:srgbClr val="1E273D"/>
                 </a:solidFill>
@@ -10797,7 +10797,7 @@
           <a:lstStyle/>
           <a:p>
             <a:r>
-              <a:rPr sz="800" b="1">
+              <a:rPr sz="1100" b="1">
                 <a:solidFill>
                   <a:srgbClr val="028090"/>
                 </a:solidFill>
@@ -10836,7 +10836,7 @@
               </a:spcAft>
             </a:pPr>
             <a:r>
-              <a:rPr sz="1200">
+              <a:rPr sz="1500">
                 <a:solidFill>
                   <a:srgbClr val="1E273D"/>
                 </a:solidFill>
@@ -10852,7 +10852,7 @@
               </a:spcAft>
             </a:pPr>
             <a:r>
-              <a:rPr sz="1200">
+              <a:rPr sz="1500">
                 <a:solidFill>
                   <a:srgbClr val="1E273D"/>
                 </a:solidFill>
@@ -10868,7 +10868,7 @@
               </a:spcAft>
             </a:pPr>
             <a:r>
-              <a:rPr sz="1200">
+              <a:rPr sz="1500">
                 <a:solidFill>
                   <a:srgbClr val="1E273D"/>
                 </a:solidFill>
@@ -10884,7 +10884,7 @@
               </a:spcAft>
             </a:pPr>
             <a:r>
-              <a:rPr sz="1200">
+              <a:rPr sz="1500">
                 <a:solidFill>
                   <a:srgbClr val="1E273D"/>
                 </a:solidFill>
@@ -10961,7 +10961,7 @@
           <a:lstStyle/>
           <a:p>
             <a:r>
-              <a:rPr sz="900" b="1">
+              <a:rPr sz="1500" b="1">
                 <a:solidFill>
                   <a:srgbClr val="F5C518"/>
                 </a:solidFill>
@@ -10996,7 +10996,7 @@
           <a:p>
             <a:pPr algn="l"/>
             <a:r>
-              <a:rPr sz="1600" b="1" i="0">
+              <a:rPr sz="1800" b="1" i="0">
                 <a:solidFill>
                   <a:srgbClr val="FFFFFF"/>
                 </a:solidFill>
@@ -11031,7 +11031,7 @@
           <a:p>
             <a:pPr algn="l"/>
             <a:r>
-              <a:rPr sz="1200" b="0" i="0">
+              <a:rPr sz="1500" b="0" i="0">
                 <a:solidFill>
                   <a:srgbClr val="CADCFC"/>
                 </a:solidFill>

</xml_diff>